<commit_message>
Update predefense presentation: add service UI screenshots
</commit_message>
<xml_diff>
--- a/deliverables/predefense_presentation_ru.pptx
+++ b/deliverables/predefense_presentation_ru.pptx
@@ -2163,6 +2163,13 @@
   <p:clrMapOvr>
     <a:masterClrMapping/>
   </p:clrMapOvr>
+  <p:timing>
+    <p:tnLst>
+      <p:par>
+        <p:cTn id="1" dur="indefinite" restart="never" nodeType="tmRoot"/>
+      </p:par>
+    </p:tnLst>
+  </p:timing>
 </p:sld>
 </file>
 
@@ -2678,6 +2685,13 @@
   <p:clrMapOvr>
     <a:masterClrMapping/>
   </p:clrMapOvr>
+  <p:timing>
+    <p:tnLst>
+      <p:par>
+        <p:cTn id="1" dur="indefinite" restart="never" nodeType="tmRoot"/>
+      </p:par>
+    </p:tnLst>
+  </p:timing>
 </p:sld>
 </file>
 
@@ -8632,45 +8646,6 @@
       </p:sp>
       <p:sp>
         <p:nvSpPr>
-          <p:cNvPr id="7" name="Text 5"/>
-          <p:cNvSpPr/>
-          <p:nvPr/>
-        </p:nvSpPr>
-        <p:spPr>
-          <a:xfrm>
-            <a:off x="941832" y="1517904"/>
-            <a:ext cx="3922776" cy="219456"/>
-          </a:xfrm>
-          <a:prstGeom prst="rect">
-            <a:avLst/>
-          </a:prstGeom>
-          <a:noFill/>
-          <a:ln/>
-        </p:spPr>
-        <p:txBody>
-          <a:bodyPr wrap="square" lIns="0" tIns="0" rIns="0" bIns="0" rtlCol="0" anchor="ctr"/>
-          <a:lstStyle/>
-          <a:p>
-            <a:pPr marL="0" indent="0">
-              <a:buNone/>
-            </a:pPr>
-            <a:r>
-              <a:rPr lang="en-US" sz="1100" dirty="0">
-                <a:solidFill>
-                  <a:srgbClr val="103F34"/>
-                </a:solidFill>
-                <a:latin typeface="Segoe UI Semibold" pitchFamily="34" charset="0"/>
-                <a:ea typeface="Segoe UI Semibold" pitchFamily="34" charset="-122"/>
-                <a:cs typeface="Segoe UI Semibold" pitchFamily="34" charset="-120"/>
-              </a:rPr>
-              <a:t>Что уже можно показать</a:t>
-            </a:r>
-            <a:endParaRPr lang="en-US" sz="1100" dirty="0"/>
-          </a:p>
-        </p:txBody>
-      </p:sp>
-      <p:sp>
-        <p:nvSpPr>
           <p:cNvPr id="8" name="Text 6"/>
           <p:cNvSpPr/>
           <p:nvPr/>
@@ -8865,11 +8840,42 @@
           </a:p>
         </p:txBody>
       </p:sp>
+      <p:pic>
+        <p:nvPicPr>
+          <p:cNvPr id="4" name="Рисунок 3"/>
+          <p:cNvPicPr>
+            <a:picLocks noChangeAspect="1"/>
+          </p:cNvPicPr>
+          <p:nvPr/>
+        </p:nvPicPr>
+        <p:blipFill>
+          <a:blip r:embed="rId3"/>
+          <a:stretch>
+            <a:fillRect/>
+          </a:stretch>
+        </p:blipFill>
+        <p:spPr>
+          <a:xfrm>
+            <a:off x="5440680" y="2747064"/>
+            <a:ext cx="5833872" cy="2925515"/>
+          </a:xfrm>
+          <a:prstGeom prst="rect">
+            <a:avLst/>
+          </a:prstGeom>
+        </p:spPr>
+      </p:pic>
     </p:spTree>
   </p:cSld>
   <p:clrMapOvr>
     <a:masterClrMapping/>
   </p:clrMapOvr>
+  <p:timing>
+    <p:tnLst>
+      <p:par>
+        <p:cTn id="1" dur="indefinite" restart="never" nodeType="tmRoot"/>
+      </p:par>
+    </p:tnLst>
+  </p:timing>
 </p:sld>
 </file>
 

</xml_diff>